<commit_message>
Apply extensive editorial revisions for SIH submission
</commit_message>
<xml_diff>
--- a/SahakarSetu_SIH2026_Final_done.pptx
+++ b/SahakarSetu_SIH2026_Final_done.pptx
@@ -4670,10 +4670,10 @@
           <p:cNvPr id="36" name="Rectangle 24">
             <a:extLst>
               <a:ext uri="{FF2B5EF4-FFF2-40B4-BE49-F238E27FC236}">
-                <a16:creationId xmlns:a16="http://schemas.microsoft.com/office/drawing/2014/main" xmlns="" id="{3E443FD7-A66B-4AA0-872D-B088B9BC5F17}"/>
+                <a16:creationId xmlns="" xmlns:a16="http://schemas.microsoft.com/office/drawing/2014/main" id="{3E443FD7-A66B-4AA0-872D-B088B9BC5F17}"/>
               </a:ext>
               <a:ext uri="{C183D7F6-B498-43B3-948B-1728B52AA6E4}">
-                <adec:decorative xmlns:adec="http://schemas.microsoft.com/office/drawing/2017/decorative" xmlns="" val="1"/>
+                <adec:decorative xmlns="" xmlns:adec="http://schemas.microsoft.com/office/drawing/2017/decorative" val="1"/>
               </a:ext>
             </a:extLst>
           </p:cNvPr>
@@ -4683,7 +4683,7 @@
           <p:nvPr>
             <p:extLst>
               <p:ext uri="{386F3935-93C4-4BCD-93E2-E3B085C9AB24}">
-                <p16:designElem xmlns:p16="http://schemas.microsoft.com/office/powerpoint/2015/main" xmlns="" val="1"/>
+                <p16:designElem xmlns="" xmlns:p16="http://schemas.microsoft.com/office/powerpoint/2015/main" val="1"/>
               </p:ext>
             </p:extLst>
           </p:nvPr>
@@ -4730,10 +4730,10 @@
           <p:cNvPr id="37" name="Freeform: Shape 26">
             <a:extLst>
               <a:ext uri="{FF2B5EF4-FFF2-40B4-BE49-F238E27FC236}">
-                <a16:creationId xmlns:a16="http://schemas.microsoft.com/office/drawing/2014/main" xmlns="" id="{C04BE0EF-3561-49B4-9A29-F283168A91C7}"/>
+                <a16:creationId xmlns="" xmlns:a16="http://schemas.microsoft.com/office/drawing/2014/main" id="{C04BE0EF-3561-49B4-9A29-F283168A91C7}"/>
               </a:ext>
               <a:ext uri="{C183D7F6-B498-43B3-948B-1728B52AA6E4}">
-                <adec:decorative xmlns:adec="http://schemas.microsoft.com/office/drawing/2017/decorative" xmlns="" val="1"/>
+                <adec:decorative xmlns="" xmlns:adec="http://schemas.microsoft.com/office/drawing/2017/decorative" val="1"/>
               </a:ext>
             </a:extLst>
           </p:cNvPr>
@@ -4743,7 +4743,7 @@
           <p:nvPr>
             <p:extLst>
               <p:ext uri="{386F3935-93C4-4BCD-93E2-E3B085C9AB24}">
-                <p16:designElem xmlns:p16="http://schemas.microsoft.com/office/powerpoint/2015/main" xmlns="" val="1"/>
+                <p16:designElem xmlns="" xmlns:p16="http://schemas.microsoft.com/office/powerpoint/2015/main" val="1"/>
               </p:ext>
             </p:extLst>
           </p:nvPr>
@@ -5504,7 +5504,7 @@
           <p:cNvPr id="5" name="Picture 4">
             <a:extLst>
               <a:ext uri="{FF2B5EF4-FFF2-40B4-BE49-F238E27FC236}">
-                <a16:creationId xmlns:a16="http://schemas.microsoft.com/office/drawing/2014/main" xmlns="" id="{9120848B-B2B4-45BE-A961-AEC0B06CF41B}"/>
+                <a16:creationId xmlns="" xmlns:a16="http://schemas.microsoft.com/office/drawing/2014/main" id="{9120848B-B2B4-45BE-A961-AEC0B06CF41B}"/>
               </a:ext>
             </a:extLst>
           </p:cNvPr>
@@ -8996,10 +8996,10 @@
           <p:cNvPr id="58" name="Oval 57" descr="Your startup LOGO">
             <a:extLst>
               <a:ext uri="{FF2B5EF4-FFF2-40B4-BE49-F238E27FC236}">
-                <a16:creationId xmlns:a16="http://schemas.microsoft.com/office/drawing/2014/main" xmlns="" id="{5DBCE864-823D-4A13-9607-5DA1F0ED5FB8}"/>
+                <a16:creationId xmlns="" xmlns:a16="http://schemas.microsoft.com/office/drawing/2014/main" id="{5DBCE864-823D-4A13-9607-5DA1F0ED5FB8}"/>
               </a:ext>
               <a:ext uri="{C183D7F6-B498-43B3-948B-1728B52AA6E4}">
-                <adec:decorative xmlns:adec="http://schemas.microsoft.com/office/drawing/2017/decorative" xmlns="" val="0"/>
+                <adec:decorative xmlns="" xmlns:adec="http://schemas.microsoft.com/office/drawing/2017/decorative" val="0"/>
               </a:ext>
             </a:extLst>
           </p:cNvPr>
@@ -9308,7 +9308,7 @@
       <p:sp>
         <p:nvSpPr>
           <p:cNvPr id="953" name="Working UI Demo Icon Disc">
-            <a:hlinkClick r:id="rId4" tooltip="Open the live SahakarSetu working website (UI demo)"/>
+            <a:hlinkClick r:id="rId6" tooltip="Open the live SahakarSetu working website (UI demo)"/>
           </p:cNvPr>
           <p:cNvSpPr/>
           <p:nvPr/>
@@ -9528,7 +9528,7 @@
           <p:cNvPr id="10" name="Rectangle 9">
             <a:extLst>
               <a:ext uri="{FF2B5EF4-FFF2-40B4-BE49-F238E27FC236}">
-                <a16:creationId xmlns:a16="http://schemas.microsoft.com/office/drawing/2014/main" xmlns="" id="{AD4F69D3-EEB0-4C4C-9434-B9960FB5854C}"/>
+                <a16:creationId xmlns="" xmlns:a16="http://schemas.microsoft.com/office/drawing/2014/main" id="{AD4F69D3-EEB0-4C4C-9434-B9960FB5854C}"/>
               </a:ext>
             </a:extLst>
           </p:cNvPr>
@@ -9693,10 +9693,10 @@
           <p:cNvPr id="67" name="Oval 66" descr="Your startup LOGO">
             <a:extLst>
               <a:ext uri="{FF2B5EF4-FFF2-40B4-BE49-F238E27FC236}">
-                <a16:creationId xmlns:a16="http://schemas.microsoft.com/office/drawing/2014/main" xmlns="" id="{5DBCE864-823D-4A13-9607-5DA1F0ED5FB8}"/>
+                <a16:creationId xmlns="" xmlns:a16="http://schemas.microsoft.com/office/drawing/2014/main" id="{5DBCE864-823D-4A13-9607-5DA1F0ED5FB8}"/>
               </a:ext>
               <a:ext uri="{C183D7F6-B498-43B3-948B-1728B52AA6E4}">
-                <adec:decorative xmlns:adec="http://schemas.microsoft.com/office/drawing/2017/decorative" xmlns="" val="0"/>
+                <adec:decorative xmlns="" xmlns:adec="http://schemas.microsoft.com/office/drawing/2017/decorative" val="0"/>
               </a:ext>
             </a:extLst>
           </p:cNvPr>
@@ -12508,7 +12508,7 @@
           <p:cNvPr id="10" name="Rectangle 9">
             <a:extLst>
               <a:ext uri="{FF2B5EF4-FFF2-40B4-BE49-F238E27FC236}">
-                <a16:creationId xmlns:a16="http://schemas.microsoft.com/office/drawing/2014/main" xmlns="" id="{AD4F69D3-EEB0-4C4C-9434-B9960FB5854C}"/>
+                <a16:creationId xmlns="" xmlns:a16="http://schemas.microsoft.com/office/drawing/2014/main" id="{AD4F69D3-EEB0-4C4C-9434-B9960FB5854C}"/>
               </a:ext>
             </a:extLst>
           </p:cNvPr>
@@ -14858,10 +14858,10 @@
           <p:cNvPr id="57" name="Oval 56" descr="Your startup LOGO">
             <a:extLst>
               <a:ext uri="{FF2B5EF4-FFF2-40B4-BE49-F238E27FC236}">
-                <a16:creationId xmlns:a16="http://schemas.microsoft.com/office/drawing/2014/main" xmlns="" id="{5DBCE864-823D-4A13-9607-5DA1F0ED5FB8}"/>
+                <a16:creationId xmlns="" xmlns:a16="http://schemas.microsoft.com/office/drawing/2014/main" id="{5DBCE864-823D-4A13-9607-5DA1F0ED5FB8}"/>
               </a:ext>
               <a:ext uri="{C183D7F6-B498-43B3-948B-1728B52AA6E4}">
-                <adec:decorative xmlns:adec="http://schemas.microsoft.com/office/drawing/2017/decorative" xmlns="" val="0"/>
+                <adec:decorative xmlns="" xmlns:adec="http://schemas.microsoft.com/office/drawing/2017/decorative" val="0"/>
               </a:ext>
             </a:extLst>
           </p:cNvPr>
@@ -15065,7 +15065,7 @@
           <p:cNvPr id="10" name="Rectangle 9">
             <a:extLst>
               <a:ext uri="{FF2B5EF4-FFF2-40B4-BE49-F238E27FC236}">
-                <a16:creationId xmlns:a16="http://schemas.microsoft.com/office/drawing/2014/main" xmlns="" id="{AD4F69D3-EEB0-4C4C-9434-B9960FB5854C}"/>
+                <a16:creationId xmlns="" xmlns:a16="http://schemas.microsoft.com/office/drawing/2014/main" id="{AD4F69D3-EEB0-4C4C-9434-B9960FB5854C}"/>
               </a:ext>
             </a:extLst>
           </p:cNvPr>
@@ -15346,10 +15346,10 @@
           <p:cNvPr id="45" name="Oval 44" descr="Your startup LOGO">
             <a:extLst>
               <a:ext uri="{FF2B5EF4-FFF2-40B4-BE49-F238E27FC236}">
-                <a16:creationId xmlns:a16="http://schemas.microsoft.com/office/drawing/2014/main" xmlns="" id="{5DBCE864-823D-4A13-9607-5DA1F0ED5FB8}"/>
+                <a16:creationId xmlns="" xmlns:a16="http://schemas.microsoft.com/office/drawing/2014/main" id="{5DBCE864-823D-4A13-9607-5DA1F0ED5FB8}"/>
               </a:ext>
               <a:ext uri="{C183D7F6-B498-43B3-948B-1728B52AA6E4}">
-                <adec:decorative xmlns:adec="http://schemas.microsoft.com/office/drawing/2017/decorative" xmlns="" val="0"/>
+                <adec:decorative xmlns="" xmlns:adec="http://schemas.microsoft.com/office/drawing/2017/decorative" val="0"/>
               </a:ext>
             </a:extLst>
           </p:cNvPr>
@@ -18766,10 +18766,10 @@
           <p:cNvPr id="19" name="Oval 18" descr="Your startup LOGO">
             <a:extLst>
               <a:ext uri="{FF2B5EF4-FFF2-40B4-BE49-F238E27FC236}">
-                <a16:creationId xmlns:a16="http://schemas.microsoft.com/office/drawing/2014/main" xmlns="" id="{5DBCE864-823D-4A13-9607-5DA1F0ED5FB8}"/>
+                <a16:creationId xmlns="" xmlns:a16="http://schemas.microsoft.com/office/drawing/2014/main" id="{5DBCE864-823D-4A13-9607-5DA1F0ED5FB8}"/>
               </a:ext>
               <a:ext uri="{C183D7F6-B498-43B3-948B-1728B52AA6E4}">
-                <adec:decorative xmlns:adec="http://schemas.microsoft.com/office/drawing/2017/decorative" xmlns="" val="0"/>
+                <adec:decorative xmlns="" xmlns:adec="http://schemas.microsoft.com/office/drawing/2017/decorative" val="0"/>
               </a:ext>
             </a:extLst>
           </p:cNvPr>
@@ -18824,7 +18824,7 @@
           <p:cNvPr id="10" name="Rectangle 9">
             <a:extLst>
               <a:ext uri="{FF2B5EF4-FFF2-40B4-BE49-F238E27FC236}">
-                <a16:creationId xmlns:a16="http://schemas.microsoft.com/office/drawing/2014/main" xmlns="" id="{AD4F69D3-EEB0-4C4C-9434-B9960FB5854C}"/>
+                <a16:creationId xmlns="" xmlns:a16="http://schemas.microsoft.com/office/drawing/2014/main" id="{AD4F69D3-EEB0-4C4C-9434-B9960FB5854C}"/>
               </a:ext>
             </a:extLst>
           </p:cNvPr>

</xml_diff>